<commit_message>
OCR B5.3 How do hormones control responses in the human body? final deck, build script, spec notes
Co-Authored-By: Claude Opus 5.5 <noreply@anthropic.com>
Claude-Session: https://claude.ai/code/session_01D8vxX3LPYz1FVkrFvM4ZxJ
</commit_message>
<xml_diff>
--- a/gcse-slides/ocr-biology/OCR21C_B5.3_Hormones_Combined.pptx
+++ b/gcse-slides/ocr-biology/OCR21C_B5.3_Hormones_Combined.pptx
@@ -7492,8 +7492,8 @@
         </p:nvSpPr>
         <p:spPr>
           <a:xfrm>
-            <a:off x="9393631" y="292608"/>
-            <a:ext cx="1837944" cy="274320"/>
+            <a:off x="9475927" y="292608"/>
+            <a:ext cx="1755648" cy="274320"/>
           </a:xfrm>
           <a:prstGeom prst="roundRect">
             <a:avLst>
@@ -7519,8 +7519,8 @@
         </p:nvSpPr>
         <p:spPr>
           <a:xfrm>
-            <a:off x="9393631" y="292608"/>
-            <a:ext cx="1837944" cy="274320"/>
+            <a:off x="9475927" y="292608"/>
+            <a:ext cx="1755648" cy="274320"/>
           </a:xfrm>
           <a:prstGeom prst="rect">
             <a:avLst/>
@@ -7544,7 +7544,7 @@
                 <a:ea typeface="Calibri" pitchFamily="34" charset="-122"/>
                 <a:cs typeface="Calibri" pitchFamily="34" charset="-120"/>
               </a:rPr>
-              <a:t>SUGGESTED PRACTICAL</a:t>
+              <a:t>SUGGESTED ACTIVITY</a:t>
             </a:r>
             <a:endParaRPr lang="en-US" sz="1000" dirty="0"/>
           </a:p>
@@ -10712,7 +10712,7 @@
         </p:nvSpPr>
         <p:spPr>
           <a:xfrm>
-            <a:off x="3264408" y="1593669"/>
+            <a:off x="3374136" y="1520517"/>
             <a:ext cx="1097280" cy="256032"/>
           </a:xfrm>
           <a:prstGeom prst="rect">
@@ -36643,8 +36643,8 @@
         </p:nvSpPr>
         <p:spPr>
           <a:xfrm>
-            <a:off x="594360" y="2697480"/>
-            <a:ext cx="1463040" cy="411480"/>
+            <a:off x="548640" y="2697480"/>
+            <a:ext cx="1234440" cy="548640"/>
           </a:xfrm>
           <a:prstGeom prst="rect">
             <a:avLst/>
@@ -36656,7 +36656,7 @@
           <a:bodyPr wrap="square" lIns="0" tIns="0" rIns="0" bIns="0" rtlCol="0" anchor="t"/>
           <a:lstStyle/>
           <a:p>
-            <a:pPr algn="ctr" indent="0" marL="0">
+            <a:pPr algn="l" indent="0" marL="0">
               <a:buNone/>
             </a:pPr>
             <a:r>
@@ -36731,8 +36731,8 @@
         </p:nvSpPr>
         <p:spPr>
           <a:xfrm>
-            <a:off x="1417320" y="2651760"/>
-            <a:ext cx="91" cy="777240"/>
+            <a:off x="1737360" y="2514600"/>
+            <a:ext cx="320040" cy="914400"/>
           </a:xfrm>
           <a:prstGeom prst="line">
             <a:avLst/>
@@ -37389,8 +37389,8 @@
         </p:nvSpPr>
         <p:spPr>
           <a:xfrm flipV="1">
-            <a:off x="3566160" y="2834640"/>
-            <a:ext cx="91" cy="411480"/>
+            <a:off x="3566160" y="2743200"/>
+            <a:ext cx="91" cy="566928"/>
           </a:xfrm>
           <a:prstGeom prst="line">
             <a:avLst/>
@@ -37554,8 +37554,8 @@
         </p:nvSpPr>
         <p:spPr>
           <a:xfrm>
-            <a:off x="2468880" y="2743200"/>
-            <a:ext cx="1600200" cy="274320"/>
+            <a:off x="2487168" y="2743200"/>
+            <a:ext cx="1005840" cy="411480"/>
           </a:xfrm>
           <a:prstGeom prst="rect">
             <a:avLst/>
@@ -37564,10 +37564,10 @@
           <a:ln/>
         </p:spPr>
         <p:txBody>
-          <a:bodyPr wrap="square" lIns="0" tIns="0" rIns="0" bIns="0" rtlCol="0" anchor="ctr"/>
+          <a:bodyPr wrap="square" lIns="0" tIns="0" rIns="0" bIns="0" rtlCol="0" anchor="t"/>
           <a:lstStyle/>
           <a:p>
-            <a:pPr algn="ctr" indent="0" marL="0">
+            <a:pPr algn="l" indent="0" marL="0">
               <a:buNone/>
             </a:pPr>
             <a:r>
@@ -38794,7 +38794,7 @@
         </p:nvSpPr>
         <p:spPr>
           <a:xfrm rot="420000">
-            <a:off x="1907438" y="2194560"/>
+            <a:off x="2136038" y="2194560"/>
             <a:ext cx="243230" cy="1607058"/>
           </a:xfrm>
           <a:prstGeom prst="roundRect">
@@ -38821,7 +38821,7 @@
         </p:nvSpPr>
         <p:spPr>
           <a:xfrm rot="-420000">
-            <a:off x="3610051" y="2194560"/>
+            <a:off x="3838651" y="2194560"/>
             <a:ext cx="243230" cy="1607058"/>
           </a:xfrm>
           <a:prstGeom prst="roundRect">
@@ -38848,7 +38848,7 @@
         </p:nvSpPr>
         <p:spPr>
           <a:xfrm>
-            <a:off x="2324405" y="3584448"/>
+            <a:off x="2553005" y="3584448"/>
             <a:ext cx="469087" cy="1693926"/>
           </a:xfrm>
           <a:prstGeom prst="roundRect">
@@ -38875,7 +38875,7 @@
         </p:nvSpPr>
         <p:spPr>
           <a:xfrm>
-            <a:off x="2967228" y="3584448"/>
+            <a:off x="3195828" y="3584448"/>
             <a:ext cx="469087" cy="1693926"/>
           </a:xfrm>
           <a:prstGeom prst="roundRect">
@@ -38902,7 +38902,7 @@
         </p:nvSpPr>
         <p:spPr>
           <a:xfrm>
-            <a:off x="2185416" y="2125066"/>
+            <a:off x="2414016" y="2125066"/>
             <a:ext cx="1389888" cy="1737360"/>
           </a:xfrm>
           <a:prstGeom prst="roundRect">
@@ -38929,7 +38929,7 @@
         </p:nvSpPr>
         <p:spPr>
           <a:xfrm>
-            <a:off x="2767432" y="1933956"/>
+            <a:off x="2996032" y="1933956"/>
             <a:ext cx="225857" cy="260604"/>
           </a:xfrm>
           <a:prstGeom prst="rect">
@@ -38954,7 +38954,7 @@
         </p:nvSpPr>
         <p:spPr>
           <a:xfrm>
-            <a:off x="2593696" y="1325880"/>
+            <a:off x="2822296" y="1325880"/>
             <a:ext cx="573329" cy="694944"/>
           </a:xfrm>
           <a:prstGeom prst="ellipse">
@@ -38979,7 +38979,7 @@
         </p:nvSpPr>
         <p:spPr>
           <a:xfrm rot="420000">
-            <a:off x="1907438" y="2194560"/>
+            <a:off x="2136038" y="2194560"/>
             <a:ext cx="243230" cy="1607058"/>
           </a:xfrm>
           <a:prstGeom prst="roundRect">
@@ -39001,7 +39001,7 @@
         </p:nvSpPr>
         <p:spPr>
           <a:xfrm rot="-420000">
-            <a:off x="3610051" y="2194560"/>
+            <a:off x="3838651" y="2194560"/>
             <a:ext cx="243230" cy="1607058"/>
           </a:xfrm>
           <a:prstGeom prst="roundRect">
@@ -39023,7 +39023,7 @@
         </p:nvSpPr>
         <p:spPr>
           <a:xfrm>
-            <a:off x="2324405" y="3584448"/>
+            <a:off x="2553005" y="3584448"/>
             <a:ext cx="469087" cy="1693926"/>
           </a:xfrm>
           <a:prstGeom prst="roundRect">
@@ -39045,7 +39045,7 @@
         </p:nvSpPr>
         <p:spPr>
           <a:xfrm>
-            <a:off x="2967228" y="3584448"/>
+            <a:off x="3195828" y="3584448"/>
             <a:ext cx="469087" cy="1693926"/>
           </a:xfrm>
           <a:prstGeom prst="roundRect">
@@ -39067,7 +39067,7 @@
         </p:nvSpPr>
         <p:spPr>
           <a:xfrm>
-            <a:off x="2185416" y="2125066"/>
+            <a:off x="2414016" y="2125066"/>
             <a:ext cx="1389888" cy="1737360"/>
           </a:xfrm>
           <a:prstGeom prst="roundRect">
@@ -39089,7 +39089,7 @@
         </p:nvSpPr>
         <p:spPr>
           <a:xfrm>
-            <a:off x="2767432" y="1933956"/>
+            <a:off x="2996032" y="1933956"/>
             <a:ext cx="225857" cy="260604"/>
           </a:xfrm>
           <a:prstGeom prst="rect">
@@ -39109,7 +39109,7 @@
         </p:nvSpPr>
         <p:spPr>
           <a:xfrm>
-            <a:off x="2593696" y="1325880"/>
+            <a:off x="2822296" y="1325880"/>
             <a:ext cx="573329" cy="694944"/>
           </a:xfrm>
           <a:prstGeom prst="ellipse">
@@ -39129,7 +39129,7 @@
         </p:nvSpPr>
         <p:spPr>
           <a:xfrm>
-            <a:off x="2880360" y="3888486"/>
+            <a:off x="3108960" y="3888486"/>
             <a:ext cx="91" cy="1346454"/>
           </a:xfrm>
           <a:prstGeom prst="line">
@@ -39152,7 +39152,7 @@
         </p:nvSpPr>
         <p:spPr>
           <a:xfrm>
-            <a:off x="2654503" y="1430122"/>
+            <a:off x="2883103" y="1430122"/>
             <a:ext cx="451714" cy="312725"/>
           </a:xfrm>
           <a:prstGeom prst="ellipse">
@@ -39177,7 +39177,7 @@
         </p:nvSpPr>
         <p:spPr>
           <a:xfrm>
-            <a:off x="2832583" y="1738503"/>
+            <a:off x="3061183" y="1738503"/>
             <a:ext cx="95555" cy="95555"/>
           </a:xfrm>
           <a:prstGeom prst="ellipse">
@@ -39202,7 +39202,7 @@
         </p:nvSpPr>
         <p:spPr>
           <a:xfrm>
-            <a:off x="2771775" y="1999107"/>
+            <a:off x="3000375" y="1999107"/>
             <a:ext cx="95555" cy="147676"/>
           </a:xfrm>
           <a:prstGeom prst="ellipse">
@@ -39227,7 +39227,7 @@
         </p:nvSpPr>
         <p:spPr>
           <a:xfrm>
-            <a:off x="2893390" y="1999107"/>
+            <a:off x="3121990" y="1999107"/>
             <a:ext cx="95555" cy="147676"/>
           </a:xfrm>
           <a:prstGeom prst="ellipse">
@@ -39252,7 +39252,7 @@
         </p:nvSpPr>
         <p:spPr>
           <a:xfrm>
-            <a:off x="2836926" y="2055571"/>
+            <a:off x="3065526" y="2055571"/>
             <a:ext cx="86868" cy="43434"/>
           </a:xfrm>
           <a:prstGeom prst="rect">
@@ -39272,7 +39272,7 @@
         </p:nvSpPr>
         <p:spPr>
           <a:xfrm>
-            <a:off x="2506828" y="3028493"/>
+            <a:off x="2735428" y="3028493"/>
             <a:ext cx="173736" cy="277978"/>
           </a:xfrm>
           <a:prstGeom prst="ellipse">
@@ -39297,7 +39297,7 @@
         </p:nvSpPr>
         <p:spPr>
           <a:xfrm>
-            <a:off x="2506828" y="2906878"/>
+            <a:off x="2735428" y="2906878"/>
             <a:ext cx="173736" cy="130302"/>
           </a:xfrm>
           <a:custGeom>
@@ -39340,7 +39340,7 @@
         </p:nvSpPr>
         <p:spPr>
           <a:xfrm>
-            <a:off x="3080156" y="3028493"/>
+            <a:off x="3308756" y="3028493"/>
             <a:ext cx="173736" cy="277978"/>
           </a:xfrm>
           <a:prstGeom prst="ellipse">
@@ -39365,7 +39365,7 @@
         </p:nvSpPr>
         <p:spPr>
           <a:xfrm>
-            <a:off x="3080156" y="2906878"/>
+            <a:off x="3308756" y="2906878"/>
             <a:ext cx="173736" cy="130302"/>
           </a:xfrm>
           <a:custGeom>
@@ -39408,7 +39408,7 @@
         </p:nvSpPr>
         <p:spPr>
           <a:xfrm rot="-600000">
-            <a:off x="2697937" y="2702738"/>
+            <a:off x="2926537" y="2702738"/>
             <a:ext cx="625450" cy="130302"/>
           </a:xfrm>
           <a:prstGeom prst="ellipse">
@@ -39433,7 +39433,7 @@
         </p:nvSpPr>
         <p:spPr>
           <a:xfrm>
-            <a:off x="2767432" y="3497580"/>
+            <a:off x="2996032" y="3497580"/>
             <a:ext cx="225857" cy="243230"/>
           </a:xfrm>
           <a:custGeom>
@@ -39476,7 +39476,7 @@
         </p:nvSpPr>
         <p:spPr>
           <a:xfrm flipH="1">
-            <a:off x="2628443" y="3514954"/>
+            <a:off x="2857043" y="3514954"/>
             <a:ext cx="147676" cy="34747"/>
           </a:xfrm>
           <a:prstGeom prst="line">
@@ -39499,7 +39499,7 @@
         </p:nvSpPr>
         <p:spPr>
           <a:xfrm>
-            <a:off x="2528545" y="3541014"/>
+            <a:off x="2757145" y="3541014"/>
             <a:ext cx="130302" cy="86868"/>
           </a:xfrm>
           <a:prstGeom prst="ellipse">
@@ -39524,7 +39524,7 @@
         </p:nvSpPr>
         <p:spPr>
           <a:xfrm>
-            <a:off x="2984602" y="3514954"/>
+            <a:off x="3213202" y="3514954"/>
             <a:ext cx="147676" cy="34747"/>
           </a:xfrm>
           <a:prstGeom prst="line">
@@ -39547,7 +39547,7 @@
         </p:nvSpPr>
         <p:spPr>
           <a:xfrm>
-            <a:off x="3101873" y="3541014"/>
+            <a:off x="3330473" y="3541014"/>
             <a:ext cx="130302" cy="86868"/>
           </a:xfrm>
           <a:prstGeom prst="ellipse">
@@ -39572,8 +39572,8 @@
         </p:nvSpPr>
         <p:spPr>
           <a:xfrm>
-            <a:off x="4114800" y="1463040"/>
-            <a:ext cx="1737360" cy="274320"/>
+            <a:off x="4224528" y="1463040"/>
+            <a:ext cx="1645920" cy="274320"/>
           </a:xfrm>
           <a:prstGeom prst="rect">
             <a:avLst/>
@@ -39611,8 +39611,8 @@
         </p:nvSpPr>
         <p:spPr>
           <a:xfrm flipH="1">
-            <a:off x="2935224" y="1600200"/>
-            <a:ext cx="1143000" cy="186080"/>
+            <a:off x="3163824" y="1600200"/>
+            <a:ext cx="1024128" cy="186080"/>
           </a:xfrm>
           <a:prstGeom prst="line">
             <a:avLst/>
@@ -39634,7 +39634,7 @@
         </p:nvSpPr>
         <p:spPr>
           <a:xfrm>
-            <a:off x="2907792" y="1758848"/>
+            <a:off x="3136392" y="1758848"/>
             <a:ext cx="54864" cy="54864"/>
           </a:xfrm>
           <a:prstGeom prst="ellipse">
@@ -39659,8 +39659,8 @@
         </p:nvSpPr>
         <p:spPr>
           <a:xfrm>
-            <a:off x="548640" y="1947672"/>
-            <a:ext cx="1600200" cy="274320"/>
+            <a:off x="502920" y="1947672"/>
+            <a:ext cx="1371600" cy="274320"/>
           </a:xfrm>
           <a:prstGeom prst="rect">
             <a:avLst/>
@@ -39698,8 +39698,8 @@
         </p:nvSpPr>
         <p:spPr>
           <a:xfrm flipV="1">
-            <a:off x="2185416" y="2072945"/>
-            <a:ext cx="576072" cy="11887"/>
+            <a:off x="1911096" y="2072945"/>
+            <a:ext cx="1078992" cy="11887"/>
           </a:xfrm>
           <a:prstGeom prst="line">
             <a:avLst/>
@@ -39721,7 +39721,7 @@
         </p:nvSpPr>
         <p:spPr>
           <a:xfrm>
-            <a:off x="2734056" y="2045513"/>
+            <a:off x="2962656" y="2045513"/>
             <a:ext cx="54864" cy="54864"/>
           </a:xfrm>
           <a:prstGeom prst="ellipse">
@@ -39746,8 +39746,8 @@
         </p:nvSpPr>
         <p:spPr>
           <a:xfrm>
-            <a:off x="548640" y="2651760"/>
-            <a:ext cx="1600200" cy="274320"/>
+            <a:off x="502920" y="2651760"/>
+            <a:ext cx="1371600" cy="274320"/>
           </a:xfrm>
           <a:prstGeom prst="rect">
             <a:avLst/>
@@ -39785,8 +39785,8 @@
         </p:nvSpPr>
         <p:spPr>
           <a:xfrm>
-            <a:off x="2185416" y="2788920"/>
-            <a:ext cx="362560" cy="196139"/>
+            <a:off x="1911096" y="2788920"/>
+            <a:ext cx="865480" cy="196139"/>
           </a:xfrm>
           <a:prstGeom prst="line">
             <a:avLst/>
@@ -39808,7 +39808,7 @@
         </p:nvSpPr>
         <p:spPr>
           <a:xfrm>
-            <a:off x="2520544" y="2957627"/>
+            <a:off x="2749144" y="2957627"/>
             <a:ext cx="54864" cy="54864"/>
           </a:xfrm>
           <a:prstGeom prst="ellipse">
@@ -39833,8 +39833,8 @@
         </p:nvSpPr>
         <p:spPr>
           <a:xfrm>
-            <a:off x="2185416" y="2788920"/>
-            <a:ext cx="981608" cy="214427"/>
+            <a:off x="1911096" y="2788920"/>
+            <a:ext cx="1484528" cy="214427"/>
           </a:xfrm>
           <a:prstGeom prst="line">
             <a:avLst/>
@@ -39856,8 +39856,8 @@
         </p:nvSpPr>
         <p:spPr>
           <a:xfrm>
-            <a:off x="4114800" y="2514600"/>
-            <a:ext cx="1737360" cy="274320"/>
+            <a:off x="4224528" y="2514600"/>
+            <a:ext cx="1645920" cy="274320"/>
           </a:xfrm>
           <a:prstGeom prst="rect">
             <a:avLst/>
@@ -39895,8 +39895,8 @@
         </p:nvSpPr>
         <p:spPr>
           <a:xfrm flipH="1">
-            <a:off x="3284982" y="2651760"/>
-            <a:ext cx="793242" cy="70409"/>
+            <a:off x="3513582" y="2651760"/>
+            <a:ext cx="674370" cy="70409"/>
           </a:xfrm>
           <a:prstGeom prst="line">
             <a:avLst/>
@@ -39918,7 +39918,7 @@
         </p:nvSpPr>
         <p:spPr>
           <a:xfrm>
-            <a:off x="3257550" y="2694737"/>
+            <a:off x="3486150" y="2694737"/>
             <a:ext cx="54864" cy="54864"/>
           </a:xfrm>
           <a:prstGeom prst="ellipse">
@@ -39943,8 +39943,8 @@
         </p:nvSpPr>
         <p:spPr>
           <a:xfrm>
-            <a:off x="548640" y="3447288"/>
-            <a:ext cx="1600200" cy="274320"/>
+            <a:off x="502920" y="3447288"/>
+            <a:ext cx="1371600" cy="274320"/>
           </a:xfrm>
           <a:prstGeom prst="rect">
             <a:avLst/>
@@ -39982,8 +39982,8 @@
         </p:nvSpPr>
         <p:spPr>
           <a:xfrm>
-            <a:off x="2185416" y="3584448"/>
-            <a:ext cx="335128" cy="91"/>
+            <a:off x="1911096" y="3584448"/>
+            <a:ext cx="838048" cy="91"/>
           </a:xfrm>
           <a:prstGeom prst="line">
             <a:avLst/>
@@ -40005,7 +40005,7 @@
         </p:nvSpPr>
         <p:spPr>
           <a:xfrm>
-            <a:off x="2493112" y="3557016"/>
+            <a:off x="2721712" y="3557016"/>
             <a:ext cx="54864" cy="54864"/>
           </a:xfrm>
           <a:prstGeom prst="ellipse">
@@ -40030,8 +40030,8 @@
         </p:nvSpPr>
         <p:spPr>
           <a:xfrm>
-            <a:off x="2185416" y="3584448"/>
-            <a:ext cx="981608" cy="18288"/>
+            <a:off x="1911096" y="3584448"/>
+            <a:ext cx="1484528" cy="18288"/>
           </a:xfrm>
           <a:prstGeom prst="line">
             <a:avLst/>
@@ -40053,8 +40053,8 @@
         </p:nvSpPr>
         <p:spPr>
           <a:xfrm>
-            <a:off x="4114800" y="3017520"/>
-            <a:ext cx="1737360" cy="384048"/>
+            <a:off x="4224528" y="3017520"/>
+            <a:ext cx="1645920" cy="384048"/>
           </a:xfrm>
           <a:prstGeom prst="rect">
             <a:avLst/>
@@ -40092,8 +40092,8 @@
         </p:nvSpPr>
         <p:spPr>
           <a:xfrm flipH="1">
-            <a:off x="3258464" y="3108960"/>
-            <a:ext cx="838048" cy="58522"/>
+            <a:off x="3487064" y="3108960"/>
+            <a:ext cx="719176" cy="58522"/>
           </a:xfrm>
           <a:prstGeom prst="line">
             <a:avLst/>
@@ -40192,13 +40192,158 @@
         </p:nvSpPr>
         <p:spPr>
           <a:xfrm>
-            <a:off x="4434840" y="4160520"/>
-            <a:ext cx="1143000" cy="411480"/>
+            <a:off x="4480560" y="4160520"/>
+            <a:ext cx="1051560" cy="365760"/>
           </a:xfrm>
           <a:prstGeom prst="roundRect">
             <a:avLst>
-              <a:gd name="adj" fmla="val 26667"/>
+              <a:gd name="adj" fmla="val 30000"/>
             </a:avLst>
+          </a:prstGeom>
+          <a:solidFill>
+            <a:srgbClr val="F6DDC8"/>
+          </a:solidFill>
+          <a:ln w="25400">
+            <a:solidFill>
+              <a:srgbClr val="B98E6E"/>
+            </a:solidFill>
+            <a:prstDash val="solid"/>
+          </a:ln>
+        </p:spPr>
+      </p:sp>
+      <p:sp>
+        <p:nvSpPr>
+          <p:cNvPr id="62" name="Shape 60"/>
+          <p:cNvSpPr/>
+          <p:nvPr/>
+        </p:nvSpPr>
+        <p:spPr>
+          <a:xfrm>
+            <a:off x="4480560" y="4297680"/>
+            <a:ext cx="329184" cy="685800"/>
+          </a:xfrm>
+          <a:prstGeom prst="roundRect">
+            <a:avLst>
+              <a:gd name="adj" fmla="val 33333"/>
+            </a:avLst>
+          </a:prstGeom>
+          <a:solidFill>
+            <a:srgbClr val="F6DDC8"/>
+          </a:solidFill>
+          <a:ln w="25400">
+            <a:solidFill>
+              <a:srgbClr val="B98E6E"/>
+            </a:solidFill>
+            <a:prstDash val="solid"/>
+          </a:ln>
+        </p:spPr>
+      </p:sp>
+      <p:sp>
+        <p:nvSpPr>
+          <p:cNvPr id="63" name="Shape 61"/>
+          <p:cNvSpPr/>
+          <p:nvPr/>
+        </p:nvSpPr>
+        <p:spPr>
+          <a:xfrm>
+            <a:off x="5202936" y="4297680"/>
+            <a:ext cx="329184" cy="685800"/>
+          </a:xfrm>
+          <a:prstGeom prst="roundRect">
+            <a:avLst>
+              <a:gd name="adj" fmla="val 33333"/>
+            </a:avLst>
+          </a:prstGeom>
+          <a:solidFill>
+            <a:srgbClr val="F6DDC8"/>
+          </a:solidFill>
+          <a:ln w="25400">
+            <a:solidFill>
+              <a:srgbClr val="B98E6E"/>
+            </a:solidFill>
+            <a:prstDash val="solid"/>
+          </a:ln>
+        </p:spPr>
+      </p:sp>
+      <p:sp>
+        <p:nvSpPr>
+          <p:cNvPr id="64" name="Shape 62"/>
+          <p:cNvSpPr/>
+          <p:nvPr/>
+        </p:nvSpPr>
+        <p:spPr>
+          <a:xfrm>
+            <a:off x="4480560" y="4160520"/>
+            <a:ext cx="1051560" cy="365760"/>
+          </a:xfrm>
+          <a:prstGeom prst="roundRect">
+            <a:avLst>
+              <a:gd name="adj" fmla="val 30000"/>
+            </a:avLst>
+          </a:prstGeom>
+          <a:solidFill>
+            <a:srgbClr val="F6DDC8"/>
+          </a:solidFill>
+          <a:ln/>
+        </p:spPr>
+      </p:sp>
+      <p:sp>
+        <p:nvSpPr>
+          <p:cNvPr id="65" name="Shape 63"/>
+          <p:cNvSpPr/>
+          <p:nvPr/>
+        </p:nvSpPr>
+        <p:spPr>
+          <a:xfrm>
+            <a:off x="4480560" y="4297680"/>
+            <a:ext cx="329184" cy="685800"/>
+          </a:xfrm>
+          <a:prstGeom prst="roundRect">
+            <a:avLst>
+              <a:gd name="adj" fmla="val 33333"/>
+            </a:avLst>
+          </a:prstGeom>
+          <a:solidFill>
+            <a:srgbClr val="F6DDC8"/>
+          </a:solidFill>
+          <a:ln/>
+        </p:spPr>
+      </p:sp>
+      <p:sp>
+        <p:nvSpPr>
+          <p:cNvPr id="66" name="Shape 64"/>
+          <p:cNvSpPr/>
+          <p:nvPr/>
+        </p:nvSpPr>
+        <p:spPr>
+          <a:xfrm>
+            <a:off x="5202936" y="4297680"/>
+            <a:ext cx="329184" cy="685800"/>
+          </a:xfrm>
+          <a:prstGeom prst="roundRect">
+            <a:avLst>
+              <a:gd name="adj" fmla="val 33333"/>
+            </a:avLst>
+          </a:prstGeom>
+          <a:solidFill>
+            <a:srgbClr val="F6DDC8"/>
+          </a:solidFill>
+          <a:ln/>
+        </p:spPr>
+      </p:sp>
+      <p:sp>
+        <p:nvSpPr>
+          <p:cNvPr id="67" name="Shape 65"/>
+          <p:cNvSpPr/>
+          <p:nvPr/>
+        </p:nvSpPr>
+        <p:spPr>
+          <a:xfrm>
+            <a:off x="4814316" y="4517136"/>
+            <a:ext cx="384048" cy="329184"/>
+          </a:xfrm>
+          <a:prstGeom prst="ellipse">
+            <a:avLst/>
           </a:prstGeom>
           <a:solidFill>
             <a:srgbClr val="F6DDC8"/>
@@ -40213,39 +40358,14 @@
       </p:sp>
       <p:sp>
         <p:nvSpPr>
-          <p:cNvPr id="62" name="Shape 60"/>
-          <p:cNvSpPr/>
-          <p:nvPr/>
-        </p:nvSpPr>
-        <p:spPr>
-          <a:xfrm>
-            <a:off x="4718304" y="4608576"/>
-            <a:ext cx="566928" cy="384048"/>
-          </a:xfrm>
-          <a:prstGeom prst="ellipse">
-            <a:avLst/>
-          </a:prstGeom>
-          <a:solidFill>
-            <a:srgbClr val="F6DDC8"/>
-          </a:solidFill>
-          <a:ln w="19050">
-            <a:solidFill>
-              <a:srgbClr val="B98E6E"/>
-            </a:solidFill>
-            <a:prstDash val="solid"/>
-          </a:ln>
-        </p:spPr>
-      </p:sp>
-      <p:sp>
-        <p:nvSpPr>
-          <p:cNvPr id="63" name="Shape 61"/>
-          <p:cNvSpPr/>
-          <p:nvPr/>
-        </p:nvSpPr>
-        <p:spPr>
-          <a:xfrm>
-            <a:off x="4773168" y="4681728"/>
-            <a:ext cx="182880" cy="237744"/>
+          <p:cNvPr id="68" name="Shape 66"/>
+          <p:cNvSpPr/>
+          <p:nvPr/>
+        </p:nvSpPr>
+        <p:spPr>
+          <a:xfrm>
+            <a:off x="4860036" y="4590288"/>
+            <a:ext cx="137160" cy="201168"/>
           </a:xfrm>
           <a:prstGeom prst="ellipse">
             <a:avLst/>
@@ -40263,14 +40383,14 @@
       </p:sp>
       <p:sp>
         <p:nvSpPr>
-          <p:cNvPr id="64" name="Shape 62"/>
-          <p:cNvSpPr/>
-          <p:nvPr/>
-        </p:nvSpPr>
-        <p:spPr>
-          <a:xfrm>
-            <a:off x="5047488" y="4681728"/>
-            <a:ext cx="182880" cy="237744"/>
+          <p:cNvPr id="69" name="Shape 67"/>
+          <p:cNvSpPr/>
+          <p:nvPr/>
+        </p:nvSpPr>
+        <p:spPr>
+          <a:xfrm>
+            <a:off x="5015484" y="4590288"/>
+            <a:ext cx="137160" cy="201168"/>
           </a:xfrm>
           <a:prstGeom prst="ellipse">
             <a:avLst/>
@@ -40288,7 +40408,7 @@
       </p:sp>
       <p:sp>
         <p:nvSpPr>
-          <p:cNvPr id="65" name="Text 63"/>
+          <p:cNvPr id="70" name="Text 68"/>
           <p:cNvSpPr/>
           <p:nvPr/>
         </p:nvSpPr>
@@ -41800,7 +41920,7 @@
       </p:graphicFrame>
       <p:sp>
         <p:nvSpPr>
-          <p:cNvPr id="67" name="Shape 64"/>
+          <p:cNvPr id="72" name="Shape 69"/>
           <p:cNvSpPr/>
           <p:nvPr/>
         </p:nvSpPr>
@@ -41827,7 +41947,7 @@
       </p:sp>
       <p:sp>
         <p:nvSpPr>
-          <p:cNvPr id="68" name="Text 65"/>
+          <p:cNvPr id="73" name="Text 70"/>
           <p:cNvSpPr/>
           <p:nvPr/>
         </p:nvSpPr>
@@ -41866,7 +41986,7 @@
       </p:sp>
       <p:sp>
         <p:nvSpPr>
-          <p:cNvPr id="69" name="Text 66"/>
+          <p:cNvPr id="74" name="Text 71"/>
           <p:cNvSpPr/>
           <p:nvPr/>
         </p:nvSpPr>
@@ -42041,7 +42161,7 @@
       </p:sp>
       <p:sp>
         <p:nvSpPr>
-          <p:cNvPr id="70" name="Shape 67"/>
+          <p:cNvPr id="75" name="Shape 72"/>
           <p:cNvSpPr/>
           <p:nvPr/>
         </p:nvSpPr>
@@ -42066,7 +42186,7 @@
       </p:sp>
       <p:sp>
         <p:nvSpPr>
-          <p:cNvPr id="71" name="Shape 68"/>
+          <p:cNvPr id="76" name="Shape 73"/>
           <p:cNvSpPr/>
           <p:nvPr/>
         </p:nvSpPr>
@@ -42091,7 +42211,7 @@
       </p:sp>
       <p:sp>
         <p:nvSpPr>
-          <p:cNvPr id="72" name="Text 69"/>
+          <p:cNvPr id="77" name="Text 74"/>
           <p:cNvSpPr/>
           <p:nvPr/>
         </p:nvSpPr>
@@ -43694,8 +43814,8 @@
         </p:nvSpPr>
         <p:spPr>
           <a:xfrm>
-            <a:off x="-126187" y="2944368"/>
-            <a:ext cx="1463040" cy="256032"/>
+            <a:off x="1002182" y="2971800"/>
+            <a:ext cx="960120" cy="256032"/>
           </a:xfrm>
           <a:prstGeom prst="rect">
             <a:avLst/>
@@ -43707,7 +43827,7 @@
           <a:bodyPr wrap="square" lIns="0" tIns="0" rIns="0" bIns="0" rtlCol="0" anchor="ctr"/>
           <a:lstStyle/>
           <a:p>
-            <a:pPr algn="ctr" indent="0" marL="0">
+            <a:pPr algn="r" indent="0" marL="0">
               <a:buNone/>
             </a:pPr>
             <a:r>
@@ -43862,8 +43982,8 @@
         </p:nvSpPr>
         <p:spPr>
           <a:xfrm>
-            <a:off x="2468880" y="2944368"/>
-            <a:ext cx="1463040" cy="256032"/>
+            <a:off x="3310128" y="2971800"/>
+            <a:ext cx="1371600" cy="256032"/>
           </a:xfrm>
           <a:prstGeom prst="rect">
             <a:avLst/>
@@ -43875,7 +43995,7 @@
           <a:bodyPr wrap="square" lIns="0" tIns="0" rIns="0" bIns="0" rtlCol="0" anchor="ctr"/>
           <a:lstStyle/>
           <a:p>
-            <a:pPr algn="ctr" indent="0" marL="0">
+            <a:pPr algn="l" indent="0" marL="0">
               <a:buNone/>
             </a:pPr>
             <a:r>
@@ -44030,8 +44150,8 @@
         </p:nvSpPr>
         <p:spPr>
           <a:xfrm>
-            <a:off x="4943246" y="2944368"/>
-            <a:ext cx="1463040" cy="256032"/>
+            <a:off x="4359859" y="2971800"/>
+            <a:ext cx="1371600" cy="256032"/>
           </a:xfrm>
           <a:prstGeom prst="rect">
             <a:avLst/>
@@ -44043,7 +44163,7 @@
           <a:bodyPr wrap="square" lIns="0" tIns="0" rIns="0" bIns="0" rtlCol="0" anchor="ctr"/>
           <a:lstStyle/>
           <a:p>
-            <a:pPr algn="ctr" indent="0" marL="0">
+            <a:pPr algn="l" indent="0" marL="0">
               <a:buNone/>
             </a:pPr>
             <a:r>
@@ -45439,7 +45559,7 @@
         <p:spPr>
           <a:xfrm>
             <a:off x="1014984" y="2011680"/>
-            <a:ext cx="4105656" cy="91"/>
+            <a:ext cx="4059936" cy="91"/>
           </a:xfrm>
           <a:prstGeom prst="line">
             <a:avLst/>
@@ -45530,7 +45650,7 @@
         </p:nvSpPr>
         <p:spPr>
           <a:xfrm>
-            <a:off x="5340096" y="2254910"/>
+            <a:off x="5340096" y="1934870"/>
             <a:ext cx="384048" cy="153619"/>
           </a:xfrm>
           <a:prstGeom prst="ellipse">
@@ -45555,7 +45675,7 @@
         </p:nvSpPr>
         <p:spPr>
           <a:xfrm>
-            <a:off x="5422392" y="2282342"/>
+            <a:off x="5422392" y="1962302"/>
             <a:ext cx="91" cy="98755"/>
           </a:xfrm>
           <a:prstGeom prst="line">
@@ -45578,7 +45698,7 @@
         </p:nvSpPr>
         <p:spPr>
           <a:xfrm>
-            <a:off x="5477256" y="2282342"/>
+            <a:off x="5477256" y="1962302"/>
             <a:ext cx="91" cy="98755"/>
           </a:xfrm>
           <a:prstGeom prst="line">
@@ -45601,7 +45721,7 @@
         </p:nvSpPr>
         <p:spPr>
           <a:xfrm>
-            <a:off x="5532120" y="2282342"/>
+            <a:off x="5532120" y="1962302"/>
             <a:ext cx="91" cy="98755"/>
           </a:xfrm>
           <a:prstGeom prst="line">
@@ -45624,7 +45744,7 @@
         </p:nvSpPr>
         <p:spPr>
           <a:xfrm>
-            <a:off x="5586984" y="2282342"/>
+            <a:off x="5586984" y="1962302"/>
             <a:ext cx="91" cy="98755"/>
           </a:xfrm>
           <a:prstGeom prst="line">
@@ -45647,7 +45767,7 @@
         </p:nvSpPr>
         <p:spPr>
           <a:xfrm>
-            <a:off x="5641848" y="2282342"/>
+            <a:off x="5641848" y="1962302"/>
             <a:ext cx="91" cy="98755"/>
           </a:xfrm>
           <a:prstGeom prst="line">
@@ -45664,7 +45784,46 @@
       </p:sp>
       <p:sp>
         <p:nvSpPr>
-          <p:cNvPr id="22" name="Shape 20"/>
+          <p:cNvPr id="22" name="Text 20"/>
+          <p:cNvSpPr/>
+          <p:nvPr/>
+        </p:nvSpPr>
+        <p:spPr>
+          <a:xfrm>
+            <a:off x="5212080" y="2148840"/>
+            <a:ext cx="640080" cy="256032"/>
+          </a:xfrm>
+          <a:prstGeom prst="rect">
+            <a:avLst/>
+          </a:prstGeom>
+          <a:noFill/>
+          <a:ln/>
+        </p:spPr>
+        <p:txBody>
+          <a:bodyPr wrap="square" lIns="0" tIns="0" rIns="0" bIns="0" rtlCol="0" anchor="ctr"/>
+          <a:lstStyle/>
+          <a:p>
+            <a:pPr algn="ctr" indent="0" marL="0">
+              <a:buNone/>
+            </a:pPr>
+            <a:r>
+              <a:rPr lang="en-US" sz="1000" i="1" dirty="0">
+                <a:solidFill>
+                  <a:srgbClr val="6B7385"/>
+                </a:solidFill>
+                <a:latin typeface="Calibri" pitchFamily="34" charset="0"/>
+                <a:ea typeface="Calibri" pitchFamily="34" charset="-122"/>
+                <a:cs typeface="Calibri" pitchFamily="34" charset="-120"/>
+              </a:rPr>
+              <a:t>muscle</a:t>
+            </a:r>
+            <a:endParaRPr lang="en-US" sz="1000" dirty="0"/>
+          </a:p>
+        </p:txBody>
+      </p:sp>
+      <p:sp>
+        <p:nvSpPr>
+          <p:cNvPr id="23" name="Shape 21"/>
           <p:cNvSpPr/>
           <p:nvPr/>
         </p:nvSpPr>
@@ -45689,7 +45848,7 @@
       </p:sp>
       <p:sp>
         <p:nvSpPr>
-          <p:cNvPr id="23" name="Shape 21"/>
+          <p:cNvPr id="24" name="Shape 22"/>
           <p:cNvSpPr/>
           <p:nvPr/>
         </p:nvSpPr>
@@ -45714,7 +45873,7 @@
       </p:sp>
       <p:sp>
         <p:nvSpPr>
-          <p:cNvPr id="24" name="Shape 22"/>
+          <p:cNvPr id="25" name="Shape 23"/>
           <p:cNvSpPr/>
           <p:nvPr/>
         </p:nvSpPr>
@@ -45739,7 +45898,7 @@
       </p:sp>
       <p:sp>
         <p:nvSpPr>
-          <p:cNvPr id="25" name="Shape 23"/>
+          <p:cNvPr id="26" name="Shape 24"/>
           <p:cNvSpPr/>
           <p:nvPr/>
         </p:nvSpPr>
@@ -45764,7 +45923,7 @@
       </p:sp>
       <p:sp>
         <p:nvSpPr>
-          <p:cNvPr id="26" name="Shape 24"/>
+          <p:cNvPr id="27" name="Shape 25"/>
           <p:cNvSpPr/>
           <p:nvPr/>
         </p:nvSpPr>
@@ -45788,7 +45947,7 @@
       </p:sp>
       <p:sp>
         <p:nvSpPr>
-          <p:cNvPr id="27" name="Text 25"/>
+          <p:cNvPr id="28" name="Text 26"/>
           <p:cNvSpPr/>
           <p:nvPr/>
         </p:nvSpPr>
@@ -45849,7 +46008,7 @@
       </p:sp>
       <p:sp>
         <p:nvSpPr>
-          <p:cNvPr id="28" name="Text 26"/>
+          <p:cNvPr id="29" name="Text 27"/>
           <p:cNvSpPr/>
           <p:nvPr/>
         </p:nvSpPr>
@@ -45899,7 +46058,7 @@
       </p:sp>
       <p:sp>
         <p:nvSpPr>
-          <p:cNvPr id="29" name="Shape 27"/>
+          <p:cNvPr id="30" name="Shape 28"/>
           <p:cNvSpPr/>
           <p:nvPr/>
         </p:nvSpPr>
@@ -45924,14 +46083,14 @@
       </p:sp>
       <p:sp>
         <p:nvSpPr>
-          <p:cNvPr id="30" name="Shape 28"/>
+          <p:cNvPr id="31" name="Shape 29"/>
           <p:cNvSpPr/>
           <p:nvPr/>
         </p:nvSpPr>
         <p:spPr>
           <a:xfrm>
             <a:off x="1097280" y="3456432"/>
-            <a:ext cx="4023360" cy="402336"/>
+            <a:ext cx="3931920" cy="402336"/>
           </a:xfrm>
           <a:prstGeom prst="roundRect">
             <a:avLst>
@@ -45951,7 +46110,7 @@
       </p:sp>
       <p:sp>
         <p:nvSpPr>
-          <p:cNvPr id="31" name="Shape 29"/>
+          <p:cNvPr id="32" name="Shape 30"/>
           <p:cNvSpPr/>
           <p:nvPr/>
         </p:nvSpPr>
@@ -45976,7 +46135,7 @@
       </p:sp>
       <p:sp>
         <p:nvSpPr>
-          <p:cNvPr id="32" name="Shape 30"/>
+          <p:cNvPr id="33" name="Shape 31"/>
           <p:cNvSpPr/>
           <p:nvPr/>
         </p:nvSpPr>
@@ -46001,7 +46160,7 @@
       </p:sp>
       <p:sp>
         <p:nvSpPr>
-          <p:cNvPr id="33" name="Shape 31"/>
+          <p:cNvPr id="34" name="Shape 32"/>
           <p:cNvSpPr/>
           <p:nvPr/>
         </p:nvSpPr>
@@ -46026,7 +46185,7 @@
       </p:sp>
       <p:sp>
         <p:nvSpPr>
-          <p:cNvPr id="34" name="Shape 32"/>
+          <p:cNvPr id="35" name="Shape 33"/>
           <p:cNvSpPr/>
           <p:nvPr/>
         </p:nvSpPr>
@@ -46051,7 +46210,7 @@
       </p:sp>
       <p:sp>
         <p:nvSpPr>
-          <p:cNvPr id="35" name="Shape 33"/>
+          <p:cNvPr id="36" name="Shape 34"/>
           <p:cNvSpPr/>
           <p:nvPr/>
         </p:nvSpPr>
@@ -46076,7 +46235,7 @@
       </p:sp>
       <p:sp>
         <p:nvSpPr>
-          <p:cNvPr id="36" name="Shape 34"/>
+          <p:cNvPr id="37" name="Shape 35"/>
           <p:cNvSpPr/>
           <p:nvPr/>
         </p:nvSpPr>
@@ -46099,7 +46258,7 @@
       </p:sp>
       <p:sp>
         <p:nvSpPr>
-          <p:cNvPr id="37" name="Shape 35"/>
+          <p:cNvPr id="38" name="Shape 36"/>
           <p:cNvSpPr/>
           <p:nvPr/>
         </p:nvSpPr>
@@ -46126,7 +46285,7 @@
       </p:sp>
       <p:sp>
         <p:nvSpPr>
-          <p:cNvPr id="38" name="Shape 36"/>
+          <p:cNvPr id="39" name="Shape 37"/>
           <p:cNvSpPr/>
           <p:nvPr/>
         </p:nvSpPr>
@@ -46151,7 +46310,7 @@
       </p:sp>
       <p:sp>
         <p:nvSpPr>
-          <p:cNvPr id="39" name="Shape 37"/>
+          <p:cNvPr id="40" name="Shape 38"/>
           <p:cNvSpPr/>
           <p:nvPr/>
         </p:nvSpPr>
@@ -46194,7 +46353,7 @@
       </p:sp>
       <p:sp>
         <p:nvSpPr>
-          <p:cNvPr id="40" name="Shape 38"/>
+          <p:cNvPr id="41" name="Shape 39"/>
           <p:cNvSpPr/>
           <p:nvPr/>
         </p:nvSpPr>
@@ -46219,7 +46378,7 @@
       </p:sp>
       <p:sp>
         <p:nvSpPr>
-          <p:cNvPr id="41" name="Shape 39"/>
+          <p:cNvPr id="42" name="Shape 40"/>
           <p:cNvSpPr/>
           <p:nvPr/>
         </p:nvSpPr>
@@ -46242,7 +46401,7 @@
       </p:sp>
       <p:sp>
         <p:nvSpPr>
-          <p:cNvPr id="42" name="Shape 40"/>
+          <p:cNvPr id="43" name="Shape 41"/>
           <p:cNvSpPr/>
           <p:nvPr/>
         </p:nvSpPr>
@@ -46269,7 +46428,7 @@
       </p:sp>
       <p:sp>
         <p:nvSpPr>
-          <p:cNvPr id="43" name="Shape 41"/>
+          <p:cNvPr id="44" name="Shape 42"/>
           <p:cNvSpPr/>
           <p:nvPr/>
         </p:nvSpPr>
@@ -46294,7 +46453,7 @@
       </p:sp>
       <p:sp>
         <p:nvSpPr>
-          <p:cNvPr id="44" name="Shape 42"/>
+          <p:cNvPr id="45" name="Shape 43"/>
           <p:cNvSpPr/>
           <p:nvPr/>
         </p:nvSpPr>
@@ -46337,7 +46496,7 @@
       </p:sp>
       <p:sp>
         <p:nvSpPr>
-          <p:cNvPr id="45" name="Shape 43"/>
+          <p:cNvPr id="46" name="Shape 44"/>
           <p:cNvSpPr/>
           <p:nvPr/>
         </p:nvSpPr>
@@ -46362,13 +46521,13 @@
       </p:sp>
       <p:sp>
         <p:nvSpPr>
-          <p:cNvPr id="46" name="Shape 44"/>
-          <p:cNvSpPr/>
-          <p:nvPr/>
-        </p:nvSpPr>
-        <p:spPr>
-          <a:xfrm>
-            <a:off x="5102352" y="3474720"/>
+          <p:cNvPr id="47" name="Shape 45"/>
+          <p:cNvSpPr/>
+          <p:nvPr/>
+        </p:nvSpPr>
+        <p:spPr>
+          <a:xfrm>
+            <a:off x="5239512" y="3474720"/>
             <a:ext cx="585216" cy="365760"/>
           </a:xfrm>
           <a:prstGeom prst="roundRect">
@@ -46389,13 +46548,13 @@
       </p:sp>
       <p:sp>
         <p:nvSpPr>
-          <p:cNvPr id="47" name="Shape 45"/>
-          <p:cNvSpPr/>
-          <p:nvPr/>
-        </p:nvSpPr>
-        <p:spPr>
-          <a:xfrm>
-            <a:off x="5303520" y="3474720"/>
+          <p:cNvPr id="48" name="Shape 46"/>
+          <p:cNvSpPr/>
+          <p:nvPr/>
+        </p:nvSpPr>
+        <p:spPr>
+          <a:xfrm>
+            <a:off x="5440680" y="3474720"/>
             <a:ext cx="182880" cy="146304"/>
           </a:xfrm>
           <a:prstGeom prst="rect">
@@ -46414,13 +46573,13 @@
       </p:sp>
       <p:sp>
         <p:nvSpPr>
-          <p:cNvPr id="48" name="Shape 46"/>
-          <p:cNvSpPr/>
-          <p:nvPr/>
-        </p:nvSpPr>
-        <p:spPr>
-          <a:xfrm>
-            <a:off x="5321808" y="3473806"/>
+          <p:cNvPr id="49" name="Shape 47"/>
+          <p:cNvSpPr/>
+          <p:nvPr/>
+        </p:nvSpPr>
+        <p:spPr>
+          <a:xfrm>
+            <a:off x="5458968" y="3473806"/>
             <a:ext cx="146304" cy="119786"/>
           </a:xfrm>
           <a:custGeom>
@@ -46457,13 +46616,13 @@
       </p:sp>
       <p:sp>
         <p:nvSpPr>
-          <p:cNvPr id="49" name="Shape 47"/>
+          <p:cNvPr id="50" name="Shape 48"/>
           <p:cNvSpPr/>
           <p:nvPr/>
         </p:nvSpPr>
         <p:spPr>
           <a:xfrm rot="10800000">
-            <a:off x="5321808" y="3465576"/>
+            <a:off x="5458968" y="3465576"/>
             <a:ext cx="146304" cy="128016"/>
           </a:xfrm>
           <a:prstGeom prst="triangle">
@@ -46482,7 +46641,7 @@
       </p:sp>
       <p:sp>
         <p:nvSpPr>
-          <p:cNvPr id="50" name="Text 48"/>
+          <p:cNvPr id="51" name="Text 49"/>
           <p:cNvSpPr/>
           <p:nvPr/>
         </p:nvSpPr>
@@ -46543,7 +46702,7 @@
       </p:sp>
       <p:sp>
         <p:nvSpPr>
-          <p:cNvPr id="51" name="Text 49"/>
+          <p:cNvPr id="52" name="Text 50"/>
           <p:cNvSpPr/>
           <p:nvPr/>
         </p:nvSpPr>
@@ -48088,7 +48247,7 @@
       </p:graphicFrame>
       <p:sp>
         <p:nvSpPr>
-          <p:cNvPr id="53" name="Shape 50"/>
+          <p:cNvPr id="54" name="Shape 51"/>
           <p:cNvSpPr/>
           <p:nvPr/>
         </p:nvSpPr>
@@ -48115,7 +48274,7 @@
       </p:sp>
       <p:sp>
         <p:nvSpPr>
-          <p:cNvPr id="54" name="Text 51"/>
+          <p:cNvPr id="55" name="Text 52"/>
           <p:cNvSpPr/>
           <p:nvPr/>
         </p:nvSpPr>
@@ -48154,7 +48313,7 @@
       </p:sp>
       <p:sp>
         <p:nvSpPr>
-          <p:cNvPr id="55" name="Text 52"/>
+          <p:cNvPr id="56" name="Text 53"/>
           <p:cNvSpPr/>
           <p:nvPr/>
         </p:nvSpPr>
@@ -48317,7 +48476,7 @@
       </p:sp>
       <p:sp>
         <p:nvSpPr>
-          <p:cNvPr id="56" name="Shape 53"/>
+          <p:cNvPr id="57" name="Shape 54"/>
           <p:cNvSpPr/>
           <p:nvPr/>
         </p:nvSpPr>
@@ -48342,7 +48501,7 @@
       </p:sp>
       <p:sp>
         <p:nvSpPr>
-          <p:cNvPr id="57" name="Shape 54"/>
+          <p:cNvPr id="58" name="Shape 55"/>
           <p:cNvSpPr/>
           <p:nvPr/>
         </p:nvSpPr>
@@ -48367,7 +48526,7 @@
       </p:sp>
       <p:sp>
         <p:nvSpPr>
-          <p:cNvPr id="58" name="Text 55"/>
+          <p:cNvPr id="59" name="Text 56"/>
           <p:cNvSpPr/>
           <p:nvPr/>
         </p:nvSpPr>

</xml_diff>